<commit_message>
Document the settings system and update sizes and test counts
README gains a Settings section, including what a browser does not let a
game control. TESTING records the four bugs found while building it and
what is not verified. DECISIONS explains the browser-controlled rows, why
post effects are off by default, music ducking, and why only training is
checkpointed.

The offline build is now 822 kB (was 738 kB) and there are 255 tests;
the deck, company site, docs and assessment pack are updated to match.
A1 gains FR-39 to FR-42.
</commit_message>
<xml_diff>
--- a/Beat-The-Hazard-Presentation.pptx
+++ b/Beat-The-Hazard-Presentation.pptx
@@ -2926,7 +2926,7 @@
                 <a:ea typeface="Consolas" pitchFamily="34" charset="-122"/>
                 <a:cs typeface="Consolas" pitchFamily="34" charset="-120"/>
               </a:rPr>
-              <a:t>204</a:t>
+              <a:t>255</a:t>
             </a:r>
             <a:endParaRPr lang="en-US" sz="2000" dirty="0"/>
           </a:p>
@@ -7191,7 +7191,7 @@
                 <a:ea typeface="Calibri" pitchFamily="34" charset="-122"/>
                 <a:cs typeface="Calibri" pitchFamily="34" charset="-120"/>
               </a:rPr>
-              <a:t>Zero third-party assets. No downloaded models, stock textures, sound files or web fonts — which means no licences to track and nothing to attribute. It also keeps the whole game to one 738 kB file.</a:t>
+              <a:t>Zero third-party assets. No downloaded models, stock textures, sound files or web fonts — which means no licences to track and nothing to attribute. It also keeps the whole game to one 822 kB file.</a:t>
             </a:r>
             <a:endParaRPr lang="en-US" sz="1300" dirty="0"/>
           </a:p>
@@ -8432,7 +8432,7 @@
                 <a:ea typeface="Consolas" pitchFamily="34" charset="-122"/>
                 <a:cs typeface="Consolas" pitchFamily="34" charset="-120"/>
               </a:rPr>
-              <a:t>204</a:t>
+              <a:t>255</a:t>
             </a:r>
             <a:endParaRPr lang="en-US" sz="2000" dirty="0"/>
           </a:p>
@@ -11935,7 +11935,7 @@
                 <a:ea typeface="Calibri" pitchFamily="34" charset="-122"/>
                 <a:cs typeface="Calibri" pitchFamily="34" charset="-120"/>
               </a:rPr>
-              <a:t>Also ships as one 738 kB file that runs offline.</a:t>
+              <a:t>Also ships as one 822 kB file that runs offline.</a:t>
             </a:r>
             <a:endParaRPr lang="en-US" sz="1150" dirty="0"/>
           </a:p>

</xml_diff>

<commit_message>
Document offline play and update sizes and test counts
README gains "Play without internet"; TESTING records how the offline
file and the service worker were verified and what was not; the status
page, deck, site and assessment pack move to 828 kB and 266 tests; A1
gains FR-43.
</commit_message>
<xml_diff>
--- a/Beat-The-Hazard-Presentation.pptx
+++ b/Beat-The-Hazard-Presentation.pptx
@@ -2926,7 +2926,7 @@
                 <a:ea typeface="Consolas" pitchFamily="34" charset="-122"/>
                 <a:cs typeface="Consolas" pitchFamily="34" charset="-120"/>
               </a:rPr>
-              <a:t>255</a:t>
+              <a:t>266</a:t>
             </a:r>
             <a:endParaRPr lang="en-US" sz="2000" dirty="0"/>
           </a:p>
@@ -7191,7 +7191,7 @@
                 <a:ea typeface="Calibri" pitchFamily="34" charset="-122"/>
                 <a:cs typeface="Calibri" pitchFamily="34" charset="-120"/>
               </a:rPr>
-              <a:t>Zero third-party assets. No downloaded models, stock textures, sound files or web fonts — which means no licences to track and nothing to attribute. It also keeps the whole game to one 822 kB file.</a:t>
+              <a:t>Zero third-party assets. No downloaded models, stock textures, sound files or web fonts — which means no licences to track and nothing to attribute. It also keeps the whole game to one 828 kB file.</a:t>
             </a:r>
             <a:endParaRPr lang="en-US" sz="1300" dirty="0"/>
           </a:p>
@@ -8432,7 +8432,7 @@
                 <a:ea typeface="Consolas" pitchFamily="34" charset="-122"/>
                 <a:cs typeface="Consolas" pitchFamily="34" charset="-120"/>
               </a:rPr>
-              <a:t>255</a:t>
+              <a:t>266</a:t>
             </a:r>
             <a:endParaRPr lang="en-US" sz="2000" dirty="0"/>
           </a:p>
@@ -11935,7 +11935,7 @@
                 <a:ea typeface="Calibri" pitchFamily="34" charset="-122"/>
                 <a:cs typeface="Calibri" pitchFamily="34" charset="-120"/>
               </a:rPr>
-              <a:t>Also ships as one 822 kB file that runs offline.</a:t>
+              <a:t>Also ships as one 828 kB file that runs offline.</a:t>
             </a:r>
             <a:endParaRPr lang="en-US" sz="1150" dirty="0"/>
           </a:p>

</xml_diff>